<commit_message>
C4 U1+U2 PowerPoints volledig in cursuskleur (themapalet → C4-rood)
De decks startten van het Office-standaardthema (accent1 blauw #4F81BD, accent3 groen,
hyperlinks #0000FF). Alles wat op het thema terugviel — stijl-fills/-lijnen, schaduwen via
effectRef, hyperlinks, tekst2 — trok daardoor naar Office-blauw/groen i.p.v. de hoofdkleur.
patch_theme() herschrijft nu het klerenschema naar de C4-rode familie (accent1 #D64550,
donkerrood/rood-tinten, rode hyperlinks) na het opslaan; .ppsx erft mee. Functionele
taalkleuren (§13, expliciete srgbClr) blijven ongemoeid. Beide decks + ppsx herbouwd.

Co-Authored-By: Claude Opus 4.8 <noreply@anthropic.com>
Claude-Session: https://claude.ai/code/session_011uXDs6Yh76Xw75Gawjhcb8
</commit_message>
<xml_diff>
--- a/03-build/pptx/C4_U1_alumno.pptx
+++ b/03-build/pptx/C4_U1_alumno.pptx
@@ -21299,34 +21299,34 @@
         <a:sysClr val="window" lastClr="FFFFFF"/>
       </a:lt1>
       <a:dk2>
-        <a:srgbClr val="1F497D"/>
+        <a:srgbClr val="20242E"/>
       </a:dk2>
       <a:lt2>
-        <a:srgbClr val="EEECE1"/>
+        <a:srgbClr val="F3EEE4"/>
       </a:lt2>
       <a:accent1>
-        <a:srgbClr val="4F81BD"/>
+        <a:srgbClr val="D64550"/>
       </a:accent1>
       <a:accent2>
-        <a:srgbClr val="C0504D"/>
+        <a:srgbClr val="A8323B"/>
       </a:accent2>
       <a:accent3>
-        <a:srgbClr val="9BBB59"/>
+        <a:srgbClr val="C25A63"/>
       </a:accent3>
       <a:accent4>
-        <a:srgbClr val="8064A2"/>
+        <a:srgbClr val="E08A90"/>
       </a:accent4>
       <a:accent5>
-        <a:srgbClr val="4BACC6"/>
+        <a:srgbClr val="9D2A33"/>
       </a:accent5>
       <a:accent6>
-        <a:srgbClr val="F79646"/>
+        <a:srgbClr val="FBEAEC"/>
       </a:accent6>
       <a:hlink>
-        <a:srgbClr val="0000FF"/>
+        <a:srgbClr val="A8323B"/>
       </a:hlink>
       <a:folHlink>
-        <a:srgbClr val="800080"/>
+        <a:srgbClr val="D64550"/>
       </a:folHlink>
     </a:clrScheme>
     <a:fontScheme name="Office">

</xml_diff>

<commit_message>
C4 U1/U2/U3 PowerPoints: video speelt nu ÍN de PowerPoint (online YouTube-embed)
Op de Escucha-dia van elk deck (docente + alumno) staat de sitcom-aflevering nu als echte,
afspeelbare online-video (PowerPoint desktop 2016+/365, internet vereist) i.p.v. enkel een
QR/verwijzing. Herbruikbare helper add_online_video(): poster (PIL, C4-rood + play-knop) +
OOXML online-video-structuur — <a:videoFile r:link> + <p14:media r:embed> (beide extern naar
youtube.com/embed/<id>) + hlinkClick ppaction://media. Per unit VIDEO_ID gezet
(U1 yvPI-4JGdyo · U2 2E51CKpanmU · U3 62GTD0QXbiI). Themapatch (C4-rood) behouden; round-trip +
video-rels geverifieerd op alle 6 decks. Regel vastgelegd in HANDOVER_C4 §3.9 zodat elke
volgende unit hem meekrijgt bij het klonen.

Co-Authored-By: Claude Opus 4.8 <noreply@anthropic.com>
Claude-Session: https://claude.ai/code/session_011uXDs6Yh76Xw75Gawjhcb8
</commit_message>
<xml_diff>
--- a/03-build/pptx/C4_U1_alumno.pptx
+++ b/03-build/pptx/C4_U1_alumno.pptx
@@ -11562,7 +11562,7 @@
         <p:spPr>
           <a:xfrm>
             <a:off x="7498079" y="1417320"/>
-            <a:ext cx="4206240" cy="3108960"/>
+            <a:ext cx="4206240" cy="2240280"/>
           </a:xfrm>
           <a:prstGeom prst="roundRect">
             <a:avLst>
@@ -11616,8 +11616,8 @@
         </p:nvSpPr>
         <p:spPr>
           <a:xfrm>
-            <a:off x="7726679" y="1600200"/>
-            <a:ext cx="3749039" cy="2834640"/>
+            <a:off x="7726679" y="1572768"/>
+            <a:ext cx="3749039" cy="2011680"/>
           </a:xfrm>
           <a:prstGeom prst="rect">
             <a:avLst/>
@@ -11642,7 +11642,7 @@
               </a:spcAft>
             </a:pPr>
             <a:r>
-              <a:rPr sz="1400" b="1" i="0">
+              <a:rPr sz="1300" b="1" i="0">
                 <a:solidFill>
                   <a:srgbClr val="A8323B"/>
                 </a:solidFill>
@@ -11664,7 +11664,7 @@
               </a:spcAft>
             </a:pPr>
             <a:r>
-              <a:rPr sz="1300" b="0" i="0">
+              <a:rPr sz="1150" b="0" i="0">
                 <a:solidFill>
                   <a:srgbClr val="20242E"/>
                 </a:solidFill>
@@ -11686,7 +11686,7 @@
               </a:spcAft>
             </a:pPr>
             <a:r>
-              <a:rPr sz="1300" b="0" i="0">
+              <a:rPr sz="1150" b="0" i="0">
                 <a:solidFill>
                   <a:srgbClr val="20242E"/>
                 </a:solidFill>
@@ -11708,7 +11708,7 @@
               </a:spcAft>
             </a:pPr>
             <a:r>
-              <a:rPr sz="1300" b="0" i="0">
+              <a:rPr sz="1150" b="0" i="0">
                 <a:solidFill>
                   <a:srgbClr val="20242E"/>
                 </a:solidFill>
@@ -11730,104 +11730,27 @@
               </a:spcAft>
             </a:pPr>
             <a:r>
-              <a:rPr sz="1300" b="0" i="0">
+              <a:rPr sz="1150" b="0" i="0">
                 <a:solidFill>
                   <a:srgbClr val="20242E"/>
                 </a:solidFill>
                 <a:latin typeface="Inter"/>
               </a:rPr>
-              <a:t>Muchas gracias · De nada</a:t>
-            </a:r>
-          </a:p>
-          <a:p>
-            <a:pPr algn="l">
-              <a:lnSpc>
-                <a:spcPct val="106000"/>
-              </a:lnSpc>
-              <a:spcBef>
-                <a:spcPts val="0"/>
-              </a:spcBef>
-              <a:spcAft>
-                <a:spcPts val="200"/>
-              </a:spcAft>
-            </a:pPr>
-            <a:r>
-              <a:rPr sz="1300" b="0" i="0">
-                <a:solidFill>
-                  <a:srgbClr val="20242E"/>
-                </a:solidFill>
-                <a:latin typeface="Inter"/>
-              </a:rPr>
-              <a:t>¡Bienvenida! · Hasta luego · Adiós</a:t>
-            </a:r>
-          </a:p>
-        </p:txBody>
-      </p:sp>
-      <p:sp>
-        <p:nvSpPr>
-          <p:cNvPr id="28" name="Rounded Rectangle 27"/>
-          <p:cNvSpPr/>
-          <p:nvPr/>
-        </p:nvSpPr>
-        <p:spPr>
-          <a:xfrm>
-            <a:off x="7498079" y="4663440"/>
-            <a:ext cx="4206240" cy="1234440"/>
-          </a:xfrm>
-          <a:prstGeom prst="roundRect">
-            <a:avLst>
-              <a:gd name="adj" fmla="val 5500"/>
-            </a:avLst>
-          </a:prstGeom>
-          <a:solidFill>
-            <a:srgbClr val="FFFFFF"/>
-          </a:solidFill>
-          <a:ln w="15240">
-            <a:solidFill>
-              <a:srgbClr val="E4E3DE"/>
-            </a:solidFill>
-          </a:ln>
-          <a:effectLst/>
-          <a:effectLst>
-            <a:outerShdw blurRad="90000" dist="38000" dir="5400000" rotWithShape="0">
-              <a:srgbClr val="20242E">
-                <a:alpha val="22000"/>
-              </a:srgbClr>
-            </a:outerShdw>
-          </a:effectLst>
-        </p:spPr>
-        <p:style>
-          <a:lnRef idx="1">
-            <a:schemeClr val="accent1"/>
-          </a:lnRef>
-          <a:fillRef idx="3">
-            <a:schemeClr val="accent1"/>
-          </a:fillRef>
-          <a:effectRef idx="2">
-            <a:schemeClr val="accent1"/>
-          </a:effectRef>
-          <a:fontRef idx="minor">
-            <a:schemeClr val="lt1"/>
-          </a:fontRef>
-        </p:style>
-        <p:txBody>
-          <a:bodyPr rtlCol="0" anchor="ctr"/>
-          <a:lstStyle/>
-          <a:p>
-            <a:pPr algn="ctr"/>
-          </a:p>
-        </p:txBody>
-      </p:sp>
-      <p:sp>
-        <p:nvSpPr>
-          <p:cNvPr id="29" name="TextBox 28"/>
+              <a:t>Muchas gracias · Hasta luego · Adiós</a:t>
+            </a:r>
+          </a:p>
+        </p:txBody>
+      </p:sp>
+      <p:sp>
+        <p:nvSpPr>
+          <p:cNvPr id="28" name="TextBox 27"/>
           <p:cNvSpPr txBox="1"/>
           <p:nvPr/>
         </p:nvSpPr>
         <p:spPr>
           <a:xfrm>
-            <a:off x="7726679" y="4800600"/>
-            <a:ext cx="3749039" cy="1005840"/>
+            <a:off x="7498079" y="3767328"/>
+            <a:ext cx="4206240" cy="274320"/>
           </a:xfrm>
           <a:prstGeom prst="rect">
             <a:avLst/>
@@ -11852,39 +11775,50 @@
               </a:spcAft>
             </a:pPr>
             <a:r>
-              <a:rPr sz="1200" b="1" i="0">
+              <a:rPr sz="1100" b="1" i="0">
                 <a:solidFill>
                   <a:srgbClr val="A8323B"/>
                 </a:solidFill>
                 <a:latin typeface="Bricolage Grotesque"/>
               </a:rPr>
-              <a:t>🎬 Vídeo online</a:t>
-            </a:r>
-          </a:p>
-          <a:p>
-            <a:pPr algn="l">
-              <a:lnSpc>
-                <a:spcPct val="106000"/>
-              </a:lnSpc>
-              <a:spcBef>
-                <a:spcPts val="0"/>
-              </a:spcBef>
-              <a:spcAft>
-                <a:spcPts val="200"/>
-              </a:spcAft>
-            </a:pPr>
-            <a:r>
-              <a:rPr sz="1100" b="0" i="0">
-                <a:solidFill>
-                  <a:srgbClr val="6A6E78"/>
-                </a:solidFill>
-                <a:latin typeface="Inter"/>
-              </a:rPr>
-              <a:t>Scan de QR op de cursus of open de digitale hub → tabblad Escucha.</a:t>
-            </a:r>
-          </a:p>
-        </p:txBody>
-      </p:sp>
+              <a:t>🎬 Sitcom · Episodio 1 — klik om af te spelen</a:t>
+            </a:r>
+          </a:p>
+        </p:txBody>
+      </p:sp>
+      <p:pic>
+        <p:nvPicPr>
+          <p:cNvPr id="29" name="Picture 28" descr="video_poster_U1.png">
+            <a:hlinkClick r:id="" action="ppaction://media"/>
+          </p:cNvPr>
+          <p:cNvPicPr>
+            <a:picLocks noChangeAspect="1"/>
+          </p:cNvPicPr>
+          <p:nvPr>
+            <a:videoFile r:link="rId3"/>
+            <p:extLst>
+              <p:ext uri="{DAA4B4D4-6D71-4841-9C94-3DE7FCFB9230}">
+                <p14:media xmlns:p14="http://schemas.microsoft.com/office/powerpoint/2010/main" r:embed="rId4"/>
+              </p:ext>
+            </p:extLst>
+          </p:nvPr>
+        </p:nvPicPr>
+        <p:blipFill>
+          <a:blip r:embed="rId2"/>
+          <a:stretch>
+            <a:fillRect/>
+          </a:stretch>
+        </p:blipFill>
+        <p:spPr>
+          <a:xfrm>
+            <a:off x="7498079" y="4069080"/>
+            <a:ext cx="4206240" cy="2331720"/>
+          </a:xfrm>
+          <a:prstGeom prst="rect">
+            <a:avLst/>
+          </a:prstGeom>
+        </p:spPr>
+      </p:pic>
       <p:sp>
         <p:nvSpPr>
           <p:cNvPr id="30" name="Rectangle 29"/>

</xml_diff>

<commit_message>
C4 funciones-laag doorgetrokken naar print + PowerPoint (U1–U3)
PRINT: gedeelde render funciones_print.py levert een «Lo que ya sé decir»-sectie die per unit
meegroeit — video-noticing (cita→función + banco) · cumulatief repertoire met exponentes per unit
+ semáforo · eindtaak-functietags · mini-reto (schrijfruimte). Bladspiegel adaptief gemeten:
U1 98% · U2 86% · U3 98% (lichte units krijgen extra ophaal-blok). Sectie tussen Música en Repaso.
POWERPOINT: nieuwe s_funciones()-dia (leest funciones_data) met het repertorio-rooster (nieuw/
nivel+ gemarkeerd) — nu 15 dia's/deck. Video-dia + C4-rood themapatch behouden en geverifieerd.

Co-Authored-By: Claude Opus 4.8 <noreply@anthropic.com>
Claude-Session: https://claude.ai/code/session_011uXDs6Yh76Xw75Gawjhcb8
</commit_message>
<xml_diff>
--- a/03-build/pptx/C4_U1_alumno.pptx
+++ b/03-build/pptx/C4_U1_alumno.pptx
@@ -18,6 +18,7 @@
     <p:sldId id="266" r:id="rId17"/>
     <p:sldId id="267" r:id="rId18"/>
     <p:sldId id="268" r:id="rId19"/>
+    <p:sldId id="269" r:id="rId20"/>
   </p:sldIdLst>
   <p:sldSz cx="12191695" cy="6858000" type="screen4x3"/>
   <p:notesSz cx="6858000" cy="9144000"/>
@@ -7339,6 +7340,1159 @@
         <p:spPr>
           <a:xfrm>
             <a:off x="502920" y="182880"/>
+            <a:ext cx="875995" cy="292608"/>
+          </a:xfrm>
+          <a:prstGeom prst="roundRect">
+            <a:avLst>
+              <a:gd name="adj" fmla="val 50000"/>
+            </a:avLst>
+          </a:prstGeom>
+          <a:solidFill>
+            <a:srgbClr val="FFFFFF"/>
+          </a:solidFill>
+          <a:ln>
+            <a:noFill/>
+          </a:ln>
+          <a:effectLst/>
+        </p:spPr>
+        <p:style>
+          <a:lnRef idx="1">
+            <a:schemeClr val="accent1"/>
+          </a:lnRef>
+          <a:fillRef idx="3">
+            <a:schemeClr val="accent1"/>
+          </a:fillRef>
+          <a:effectRef idx="2">
+            <a:schemeClr val="accent1"/>
+          </a:effectRef>
+          <a:fontRef idx="minor">
+            <a:schemeClr val="lt1"/>
+          </a:fontRef>
+        </p:style>
+        <p:txBody>
+          <a:bodyPr rtlCol="0" anchor="ctr" wrap="none" lIns="88900" rIns="88900" tIns="12700" bIns="12700"/>
+          <a:lstStyle/>
+          <a:p>
+            <a:pPr algn="ctr"/>
+            <a:r>
+              <a:rPr sz="1100" b="1">
+                <a:solidFill>
+                  <a:srgbClr val="D64550"/>
+                </a:solidFill>
+                <a:latin typeface="Inter"/>
+              </a:rPr>
+              <a:t>FUNCIONES</a:t>
+            </a:r>
+          </a:p>
+        </p:txBody>
+      </p:sp>
+      <p:sp>
+        <p:nvSpPr>
+          <p:cNvPr id="6" name="TextBox 5"/>
+          <p:cNvSpPr txBox="1"/>
+          <p:nvPr/>
+        </p:nvSpPr>
+        <p:spPr>
+          <a:xfrm>
+            <a:off x="457200" y="457200"/>
+            <a:ext cx="9692640" cy="502920"/>
+          </a:xfrm>
+          <a:prstGeom prst="rect">
+            <a:avLst/>
+          </a:prstGeom>
+          <a:noFill/>
+        </p:spPr>
+        <p:txBody>
+          <a:bodyPr wrap="square" anchor="ctr" lIns="38100" rIns="38100" tIns="25400" bIns="25400">
+            <a:spAutoFit/>
+          </a:bodyPr>
+          <a:lstStyle/>
+          <a:p>
+            <a:pPr algn="l">
+              <a:lnSpc>
+                <a:spcPct val="106000"/>
+              </a:lnSpc>
+              <a:spcBef>
+                <a:spcPts val="0"/>
+              </a:spcBef>
+              <a:spcAft>
+                <a:spcPts val="200"/>
+              </a:spcAft>
+            </a:pPr>
+            <a:r>
+              <a:rPr sz="2700" b="1" i="0">
+                <a:solidFill>
+                  <a:srgbClr val="FFFFFF"/>
+                </a:solidFill>
+                <a:latin typeface="Bricolage Grotesque"/>
+              </a:rPr>
+              <a:t>Mis funciones comunicativas</a:t>
+            </a:r>
+          </a:p>
+        </p:txBody>
+      </p:sp>
+      <p:sp>
+        <p:nvSpPr>
+          <p:cNvPr id="7" name="TextBox 6"/>
+          <p:cNvSpPr txBox="1"/>
+          <p:nvPr/>
+        </p:nvSpPr>
+        <p:spPr>
+          <a:xfrm>
+            <a:off x="502920" y="932688"/>
+            <a:ext cx="9692640" cy="274320"/>
+          </a:xfrm>
+          <a:prstGeom prst="rect">
+            <a:avLst/>
+          </a:prstGeom>
+          <a:noFill/>
+        </p:spPr>
+        <p:txBody>
+          <a:bodyPr wrap="square" anchor="t" lIns="38100" rIns="38100" tIns="25400" bIns="25400">
+            <a:spAutoFit/>
+          </a:bodyPr>
+          <a:lstStyle/>
+          <a:p>
+            <a:pPr algn="l">
+              <a:lnSpc>
+                <a:spcPct val="106000"/>
+              </a:lnSpc>
+              <a:spcBef>
+                <a:spcPts val="0"/>
+              </a:spcBef>
+              <a:spcAft>
+                <a:spcPts val="200"/>
+              </a:spcAft>
+            </a:pPr>
+            <a:r>
+              <a:rPr sz="1250" b="0" i="1">
+                <a:solidFill>
+                  <a:srgbClr val="FBEAEC"/>
+                </a:solidFill>
+                <a:latin typeface="Inter"/>
+              </a:rPr>
+              <a:t>Lo que ya sé hacer — crece cada unidad</a:t>
+            </a:r>
+          </a:p>
+        </p:txBody>
+      </p:sp>
+      <p:sp>
+        <p:nvSpPr>
+          <p:cNvPr id="8" name="TextBox 7"/>
+          <p:cNvSpPr txBox="1"/>
+          <p:nvPr/>
+        </p:nvSpPr>
+        <p:spPr>
+          <a:xfrm>
+            <a:off x="548640" y="1298448"/>
+            <a:ext cx="11155680" cy="320040"/>
+          </a:xfrm>
+          <a:prstGeom prst="rect">
+            <a:avLst/>
+          </a:prstGeom>
+          <a:noFill/>
+        </p:spPr>
+        <p:txBody>
+          <a:bodyPr wrap="square" anchor="t" lIns="38100" rIns="38100" tIns="25400" bIns="25400">
+            <a:spAutoFit/>
+          </a:bodyPr>
+          <a:lstStyle/>
+          <a:p>
+            <a:pPr algn="l">
+              <a:lnSpc>
+                <a:spcPct val="106000"/>
+              </a:lnSpc>
+              <a:spcBef>
+                <a:spcPts val="0"/>
+              </a:spcBef>
+              <a:spcAft>
+                <a:spcPts val="200"/>
+              </a:spcAft>
+            </a:pPr>
+            <a:r>
+              <a:rPr sz="1300" b="1" i="0">
+                <a:solidFill>
+                  <a:srgbClr val="A8323B"/>
+                </a:solidFill>
+                <a:latin typeface="Bricolage Grotesque"/>
+              </a:rPr>
+              <a:t>Mi repertorio: 4 / 8 funciones — </a:t>
+            </a:r>
+            <a:r>
+              <a:rPr sz="1200" b="0" i="0">
+                <a:solidFill>
+                  <a:srgbClr val="6A6E78"/>
+                </a:solidFill>
+                <a:latin typeface="Inter"/>
+              </a:rPr>
+              <a:t>no solo palabras: lo que puedo HACER con el español.</a:t>
+            </a:r>
+          </a:p>
+        </p:txBody>
+      </p:sp>
+      <p:sp>
+        <p:nvSpPr>
+          <p:cNvPr id="9" name="Rounded Rectangle 8"/>
+          <p:cNvSpPr/>
+          <p:nvPr/>
+        </p:nvSpPr>
+        <p:spPr>
+          <a:xfrm>
+            <a:off x="502920" y="1691640"/>
+            <a:ext cx="5394960" cy="1060704"/>
+          </a:xfrm>
+          <a:prstGeom prst="roundRect">
+            <a:avLst>
+              <a:gd name="adj" fmla="val 5500"/>
+            </a:avLst>
+          </a:prstGeom>
+          <a:solidFill>
+            <a:srgbClr val="FBEAEC"/>
+          </a:solidFill>
+          <a:ln w="15240">
+            <a:solidFill>
+              <a:srgbClr val="D64550"/>
+            </a:solidFill>
+          </a:ln>
+          <a:effectLst/>
+          <a:effectLst>
+            <a:outerShdw blurRad="90000" dist="38000" dir="5400000" rotWithShape="0">
+              <a:srgbClr val="20242E">
+                <a:alpha val="22000"/>
+              </a:srgbClr>
+            </a:outerShdw>
+          </a:effectLst>
+        </p:spPr>
+        <p:style>
+          <a:lnRef idx="1">
+            <a:schemeClr val="accent1"/>
+          </a:lnRef>
+          <a:fillRef idx="3">
+            <a:schemeClr val="accent1"/>
+          </a:fillRef>
+          <a:effectRef idx="2">
+            <a:schemeClr val="accent1"/>
+          </a:effectRef>
+          <a:fontRef idx="minor">
+            <a:schemeClr val="lt1"/>
+          </a:fontRef>
+        </p:style>
+        <p:txBody>
+          <a:bodyPr rtlCol="0" anchor="ctr"/>
+          <a:lstStyle/>
+          <a:p>
+            <a:pPr algn="ctr"/>
+          </a:p>
+        </p:txBody>
+      </p:sp>
+      <p:sp>
+        <p:nvSpPr>
+          <p:cNvPr id="10" name="TextBox 9"/>
+          <p:cNvSpPr txBox="1"/>
+          <p:nvPr/>
+        </p:nvSpPr>
+        <p:spPr>
+          <a:xfrm>
+            <a:off x="704088" y="1801368"/>
+            <a:ext cx="4992624" cy="365760"/>
+          </a:xfrm>
+          <a:prstGeom prst="rect">
+            <a:avLst/>
+          </a:prstGeom>
+          <a:noFill/>
+        </p:spPr>
+        <p:txBody>
+          <a:bodyPr wrap="square" anchor="t" lIns="38100" rIns="38100" tIns="25400" bIns="25400">
+            <a:spAutoFit/>
+          </a:bodyPr>
+          <a:lstStyle/>
+          <a:p>
+            <a:pPr algn="l">
+              <a:lnSpc>
+                <a:spcPct val="106000"/>
+              </a:lnSpc>
+              <a:spcBef>
+                <a:spcPts val="0"/>
+              </a:spcBef>
+              <a:spcAft>
+                <a:spcPts val="200"/>
+              </a:spcAft>
+            </a:pPr>
+            <a:r>
+              <a:rPr sz="1250" b="1" i="0">
+                <a:solidFill>
+                  <a:srgbClr val="20242E"/>
+                </a:solidFill>
+                <a:latin typeface="Bricolage Grotesque"/>
+              </a:rPr>
+              <a:t>Saludar y despedirse</a:t>
+            </a:r>
+            <a:r>
+              <a:rPr sz="900" b="1" i="0">
+                <a:solidFill>
+                  <a:srgbClr val="A8323B"/>
+                </a:solidFill>
+                <a:latin typeface="Inter"/>
+              </a:rPr>
+              <a:t>  ● NUEVA</a:t>
+            </a:r>
+          </a:p>
+        </p:txBody>
+      </p:sp>
+      <p:sp>
+        <p:nvSpPr>
+          <p:cNvPr id="11" name="TextBox 10"/>
+          <p:cNvSpPr txBox="1"/>
+          <p:nvPr/>
+        </p:nvSpPr>
+        <p:spPr>
+          <a:xfrm>
+            <a:off x="704088" y="2194560"/>
+            <a:ext cx="4992624" cy="502920"/>
+          </a:xfrm>
+          <a:prstGeom prst="rect">
+            <a:avLst/>
+          </a:prstGeom>
+          <a:noFill/>
+        </p:spPr>
+        <p:txBody>
+          <a:bodyPr wrap="square" anchor="t" lIns="38100" rIns="38100" tIns="25400" bIns="25400">
+            <a:spAutoFit/>
+          </a:bodyPr>
+          <a:lstStyle/>
+          <a:p>
+            <a:pPr algn="l">
+              <a:lnSpc>
+                <a:spcPct val="106000"/>
+              </a:lnSpc>
+              <a:spcBef>
+                <a:spcPts val="0"/>
+              </a:spcBef>
+              <a:spcAft>
+                <a:spcPts val="200"/>
+              </a:spcAft>
+            </a:pPr>
+            <a:r>
+              <a:rPr sz="900" b="0" i="0">
+                <a:solidFill>
+                  <a:srgbClr val="6A6E78"/>
+                </a:solidFill>
+                <a:latin typeface="Inter"/>
+              </a:rPr>
+              <a:t>Hola · Adiós · Hasta luego</a:t>
+            </a:r>
+          </a:p>
+        </p:txBody>
+      </p:sp>
+      <p:sp>
+        <p:nvSpPr>
+          <p:cNvPr id="12" name="Rounded Rectangle 11"/>
+          <p:cNvSpPr/>
+          <p:nvPr/>
+        </p:nvSpPr>
+        <p:spPr>
+          <a:xfrm>
+            <a:off x="6263640" y="1691640"/>
+            <a:ext cx="5394960" cy="1060704"/>
+          </a:xfrm>
+          <a:prstGeom prst="roundRect">
+            <a:avLst>
+              <a:gd name="adj" fmla="val 5500"/>
+            </a:avLst>
+          </a:prstGeom>
+          <a:solidFill>
+            <a:srgbClr val="FBEAEC"/>
+          </a:solidFill>
+          <a:ln w="15240">
+            <a:solidFill>
+              <a:srgbClr val="D64550"/>
+            </a:solidFill>
+          </a:ln>
+          <a:effectLst/>
+          <a:effectLst>
+            <a:outerShdw blurRad="90000" dist="38000" dir="5400000" rotWithShape="0">
+              <a:srgbClr val="20242E">
+                <a:alpha val="22000"/>
+              </a:srgbClr>
+            </a:outerShdw>
+          </a:effectLst>
+        </p:spPr>
+        <p:style>
+          <a:lnRef idx="1">
+            <a:schemeClr val="accent1"/>
+          </a:lnRef>
+          <a:fillRef idx="3">
+            <a:schemeClr val="accent1"/>
+          </a:fillRef>
+          <a:effectRef idx="2">
+            <a:schemeClr val="accent1"/>
+          </a:effectRef>
+          <a:fontRef idx="minor">
+            <a:schemeClr val="lt1"/>
+          </a:fontRef>
+        </p:style>
+        <p:txBody>
+          <a:bodyPr rtlCol="0" anchor="ctr"/>
+          <a:lstStyle/>
+          <a:p>
+            <a:pPr algn="ctr"/>
+          </a:p>
+        </p:txBody>
+      </p:sp>
+      <p:sp>
+        <p:nvSpPr>
+          <p:cNvPr id="13" name="TextBox 12"/>
+          <p:cNvSpPr txBox="1"/>
+          <p:nvPr/>
+        </p:nvSpPr>
+        <p:spPr>
+          <a:xfrm>
+            <a:off x="6464808" y="1801368"/>
+            <a:ext cx="4992624" cy="365760"/>
+          </a:xfrm>
+          <a:prstGeom prst="rect">
+            <a:avLst/>
+          </a:prstGeom>
+          <a:noFill/>
+        </p:spPr>
+        <p:txBody>
+          <a:bodyPr wrap="square" anchor="t" lIns="38100" rIns="38100" tIns="25400" bIns="25400">
+            <a:spAutoFit/>
+          </a:bodyPr>
+          <a:lstStyle/>
+          <a:p>
+            <a:pPr algn="l">
+              <a:lnSpc>
+                <a:spcPct val="106000"/>
+              </a:lnSpc>
+              <a:spcBef>
+                <a:spcPts val="0"/>
+              </a:spcBef>
+              <a:spcAft>
+                <a:spcPts val="200"/>
+              </a:spcAft>
+            </a:pPr>
+            <a:r>
+              <a:rPr sz="1250" b="1" i="0">
+                <a:solidFill>
+                  <a:srgbClr val="20242E"/>
+                </a:solidFill>
+                <a:latin typeface="Bricolage Grotesque"/>
+              </a:rPr>
+              <a:t>Presentarse (decir quién soy)</a:t>
+            </a:r>
+            <a:r>
+              <a:rPr sz="900" b="1" i="0">
+                <a:solidFill>
+                  <a:srgbClr val="A8323B"/>
+                </a:solidFill>
+                <a:latin typeface="Inter"/>
+              </a:rPr>
+              <a:t>  ● NUEVA</a:t>
+            </a:r>
+          </a:p>
+        </p:txBody>
+      </p:sp>
+      <p:sp>
+        <p:nvSpPr>
+          <p:cNvPr id="14" name="TextBox 13"/>
+          <p:cNvSpPr txBox="1"/>
+          <p:nvPr/>
+        </p:nvSpPr>
+        <p:spPr>
+          <a:xfrm>
+            <a:off x="6464808" y="2194560"/>
+            <a:ext cx="4992624" cy="502920"/>
+          </a:xfrm>
+          <a:prstGeom prst="rect">
+            <a:avLst/>
+          </a:prstGeom>
+          <a:noFill/>
+        </p:spPr>
+        <p:txBody>
+          <a:bodyPr wrap="square" anchor="t" lIns="38100" rIns="38100" tIns="25400" bIns="25400">
+            <a:spAutoFit/>
+          </a:bodyPr>
+          <a:lstStyle/>
+          <a:p>
+            <a:pPr algn="l">
+              <a:lnSpc>
+                <a:spcPct val="106000"/>
+              </a:lnSpc>
+              <a:spcBef>
+                <a:spcPts val="0"/>
+              </a:spcBef>
+              <a:spcAft>
+                <a:spcPts val="200"/>
+              </a:spcAft>
+            </a:pPr>
+            <a:r>
+              <a:rPr sz="900" b="0" i="0">
+                <a:solidFill>
+                  <a:srgbClr val="6A6E78"/>
+                </a:solidFill>
+                <a:latin typeface="Inter"/>
+              </a:rPr>
+              <a:t>Me llamo… · (Yo) soy… · Encantado/a</a:t>
+            </a:r>
+          </a:p>
+        </p:txBody>
+      </p:sp>
+      <p:sp>
+        <p:nvSpPr>
+          <p:cNvPr id="15" name="Rounded Rectangle 14"/>
+          <p:cNvSpPr/>
+          <p:nvPr/>
+        </p:nvSpPr>
+        <p:spPr>
+          <a:xfrm>
+            <a:off x="502920" y="2898648"/>
+            <a:ext cx="5394960" cy="1060704"/>
+          </a:xfrm>
+          <a:prstGeom prst="roundRect">
+            <a:avLst>
+              <a:gd name="adj" fmla="val 5500"/>
+            </a:avLst>
+          </a:prstGeom>
+          <a:solidFill>
+            <a:srgbClr val="FBEAEC"/>
+          </a:solidFill>
+          <a:ln w="15240">
+            <a:solidFill>
+              <a:srgbClr val="D64550"/>
+            </a:solidFill>
+          </a:ln>
+          <a:effectLst/>
+          <a:effectLst>
+            <a:outerShdw blurRad="90000" dist="38000" dir="5400000" rotWithShape="0">
+              <a:srgbClr val="20242E">
+                <a:alpha val="22000"/>
+              </a:srgbClr>
+            </a:outerShdw>
+          </a:effectLst>
+        </p:spPr>
+        <p:style>
+          <a:lnRef idx="1">
+            <a:schemeClr val="accent1"/>
+          </a:lnRef>
+          <a:fillRef idx="3">
+            <a:schemeClr val="accent1"/>
+          </a:fillRef>
+          <a:effectRef idx="2">
+            <a:schemeClr val="accent1"/>
+          </a:effectRef>
+          <a:fontRef idx="minor">
+            <a:schemeClr val="lt1"/>
+          </a:fontRef>
+        </p:style>
+        <p:txBody>
+          <a:bodyPr rtlCol="0" anchor="ctr"/>
+          <a:lstStyle/>
+          <a:p>
+            <a:pPr algn="ctr"/>
+          </a:p>
+        </p:txBody>
+      </p:sp>
+      <p:sp>
+        <p:nvSpPr>
+          <p:cNvPr id="16" name="TextBox 15"/>
+          <p:cNvSpPr txBox="1"/>
+          <p:nvPr/>
+        </p:nvSpPr>
+        <p:spPr>
+          <a:xfrm>
+            <a:off x="704088" y="3008376"/>
+            <a:ext cx="4992624" cy="365760"/>
+          </a:xfrm>
+          <a:prstGeom prst="rect">
+            <a:avLst/>
+          </a:prstGeom>
+          <a:noFill/>
+        </p:spPr>
+        <p:txBody>
+          <a:bodyPr wrap="square" anchor="t" lIns="38100" rIns="38100" tIns="25400" bIns="25400">
+            <a:spAutoFit/>
+          </a:bodyPr>
+          <a:lstStyle/>
+          <a:p>
+            <a:pPr algn="l">
+              <a:lnSpc>
+                <a:spcPct val="106000"/>
+              </a:lnSpc>
+              <a:spcBef>
+                <a:spcPts val="0"/>
+              </a:spcBef>
+              <a:spcAft>
+                <a:spcPts val="200"/>
+              </a:spcAft>
+            </a:pPr>
+            <a:r>
+              <a:rPr sz="1250" b="1" i="0">
+                <a:solidFill>
+                  <a:srgbClr val="20242E"/>
+                </a:solidFill>
+                <a:latin typeface="Bricolage Grotesque"/>
+              </a:rPr>
+              <a:t>Pedir y dar información personal</a:t>
+            </a:r>
+            <a:r>
+              <a:rPr sz="900" b="1" i="0">
+                <a:solidFill>
+                  <a:srgbClr val="A8323B"/>
+                </a:solidFill>
+                <a:latin typeface="Inter"/>
+              </a:rPr>
+              <a:t>  ● NUEVA</a:t>
+            </a:r>
+          </a:p>
+        </p:txBody>
+      </p:sp>
+      <p:sp>
+        <p:nvSpPr>
+          <p:cNvPr id="17" name="TextBox 16"/>
+          <p:cNvSpPr txBox="1"/>
+          <p:nvPr/>
+        </p:nvSpPr>
+        <p:spPr>
+          <a:xfrm>
+            <a:off x="704088" y="3401568"/>
+            <a:ext cx="4992624" cy="502920"/>
+          </a:xfrm>
+          <a:prstGeom prst="rect">
+            <a:avLst/>
+          </a:prstGeom>
+          <a:noFill/>
+        </p:spPr>
+        <p:txBody>
+          <a:bodyPr wrap="square" anchor="t" lIns="38100" rIns="38100" tIns="25400" bIns="25400">
+            <a:spAutoFit/>
+          </a:bodyPr>
+          <a:lstStyle/>
+          <a:p>
+            <a:pPr algn="l">
+              <a:lnSpc>
+                <a:spcPct val="106000"/>
+              </a:lnSpc>
+              <a:spcBef>
+                <a:spcPts val="0"/>
+              </a:spcBef>
+              <a:spcAft>
+                <a:spcPts val="200"/>
+              </a:spcAft>
+            </a:pPr>
+            <a:r>
+              <a:rPr sz="900" b="0" i="0">
+                <a:solidFill>
+                  <a:srgbClr val="6A6E78"/>
+                </a:solidFill>
+                <a:latin typeface="Inter"/>
+              </a:rPr>
+              <a:t>¿Cómo te llamas? · ¿Y tú?</a:t>
+            </a:r>
+          </a:p>
+        </p:txBody>
+      </p:sp>
+      <p:sp>
+        <p:nvSpPr>
+          <p:cNvPr id="18" name="Rounded Rectangle 17"/>
+          <p:cNvSpPr/>
+          <p:nvPr/>
+        </p:nvSpPr>
+        <p:spPr>
+          <a:xfrm>
+            <a:off x="6263640" y="2898648"/>
+            <a:ext cx="5394960" cy="1060704"/>
+          </a:xfrm>
+          <a:prstGeom prst="roundRect">
+            <a:avLst>
+              <a:gd name="adj" fmla="val 5500"/>
+            </a:avLst>
+          </a:prstGeom>
+          <a:solidFill>
+            <a:srgbClr val="FBEAEC"/>
+          </a:solidFill>
+          <a:ln w="15240">
+            <a:solidFill>
+              <a:srgbClr val="D64550"/>
+            </a:solidFill>
+          </a:ln>
+          <a:effectLst/>
+          <a:effectLst>
+            <a:outerShdw blurRad="90000" dist="38000" dir="5400000" rotWithShape="0">
+              <a:srgbClr val="20242E">
+                <a:alpha val="22000"/>
+              </a:srgbClr>
+            </a:outerShdw>
+          </a:effectLst>
+        </p:spPr>
+        <p:style>
+          <a:lnRef idx="1">
+            <a:schemeClr val="accent1"/>
+          </a:lnRef>
+          <a:fillRef idx="3">
+            <a:schemeClr val="accent1"/>
+          </a:fillRef>
+          <a:effectRef idx="2">
+            <a:schemeClr val="accent1"/>
+          </a:effectRef>
+          <a:fontRef idx="minor">
+            <a:schemeClr val="lt1"/>
+          </a:fontRef>
+        </p:style>
+        <p:txBody>
+          <a:bodyPr rtlCol="0" anchor="ctr"/>
+          <a:lstStyle/>
+          <a:p>
+            <a:pPr algn="ctr"/>
+          </a:p>
+        </p:txBody>
+      </p:sp>
+      <p:sp>
+        <p:nvSpPr>
+          <p:cNvPr id="19" name="TextBox 18"/>
+          <p:cNvSpPr txBox="1"/>
+          <p:nvPr/>
+        </p:nvSpPr>
+        <p:spPr>
+          <a:xfrm>
+            <a:off x="6464808" y="3008376"/>
+            <a:ext cx="4992624" cy="365760"/>
+          </a:xfrm>
+          <a:prstGeom prst="rect">
+            <a:avLst/>
+          </a:prstGeom>
+          <a:noFill/>
+        </p:spPr>
+        <p:txBody>
+          <a:bodyPr wrap="square" anchor="t" lIns="38100" rIns="38100" tIns="25400" bIns="25400">
+            <a:spAutoFit/>
+          </a:bodyPr>
+          <a:lstStyle/>
+          <a:p>
+            <a:pPr algn="l">
+              <a:lnSpc>
+                <a:spcPct val="106000"/>
+              </a:lnSpc>
+              <a:spcBef>
+                <a:spcPts val="0"/>
+              </a:spcBef>
+              <a:spcAft>
+                <a:spcPts val="200"/>
+              </a:spcAft>
+            </a:pPr>
+            <a:r>
+              <a:rPr sz="1250" b="1" i="0">
+                <a:solidFill>
+                  <a:srgbClr val="20242E"/>
+                </a:solidFill>
+                <a:latin typeface="Bricolage Grotesque"/>
+              </a:rPr>
+              <a:t>Gestionar la comprensión</a:t>
+            </a:r>
+            <a:r>
+              <a:rPr sz="900" b="1" i="0">
+                <a:solidFill>
+                  <a:srgbClr val="A8323B"/>
+                </a:solidFill>
+                <a:latin typeface="Inter"/>
+              </a:rPr>
+              <a:t>  ● NUEVA</a:t>
+            </a:r>
+          </a:p>
+        </p:txBody>
+      </p:sp>
+      <p:sp>
+        <p:nvSpPr>
+          <p:cNvPr id="20" name="TextBox 19"/>
+          <p:cNvSpPr txBox="1"/>
+          <p:nvPr/>
+        </p:nvSpPr>
+        <p:spPr>
+          <a:xfrm>
+            <a:off x="6464808" y="3401568"/>
+            <a:ext cx="4992624" cy="502920"/>
+          </a:xfrm>
+          <a:prstGeom prst="rect">
+            <a:avLst/>
+          </a:prstGeom>
+          <a:noFill/>
+        </p:spPr>
+        <p:txBody>
+          <a:bodyPr wrap="square" anchor="t" lIns="38100" rIns="38100" tIns="25400" bIns="25400">
+            <a:spAutoFit/>
+          </a:bodyPr>
+          <a:lstStyle/>
+          <a:p>
+            <a:pPr algn="l">
+              <a:lnSpc>
+                <a:spcPct val="106000"/>
+              </a:lnSpc>
+              <a:spcBef>
+                <a:spcPts val="0"/>
+              </a:spcBef>
+              <a:spcAft>
+                <a:spcPts val="200"/>
+              </a:spcAft>
+            </a:pPr>
+            <a:r>
+              <a:rPr sz="900" b="0" i="0">
+                <a:solidFill>
+                  <a:srgbClr val="6A6E78"/>
+                </a:solidFill>
+                <a:latin typeface="Inter"/>
+              </a:rPr>
+              <a:t>¿Cómo? · Otra vez, por favor</a:t>
+            </a:r>
+          </a:p>
+        </p:txBody>
+      </p:sp>
+      <p:sp>
+        <p:nvSpPr>
+          <p:cNvPr id="21" name="Rectangle 20"/>
+          <p:cNvSpPr/>
+          <p:nvPr/>
+        </p:nvSpPr>
+        <p:spPr>
+          <a:xfrm>
+            <a:off x="0" y="6547104"/>
+            <a:ext cx="12191695" cy="310896"/>
+          </a:xfrm>
+          <a:prstGeom prst="rect">
+            <a:avLst/>
+          </a:prstGeom>
+          <a:solidFill>
+            <a:srgbClr val="F3EEE4"/>
+          </a:solidFill>
+          <a:ln>
+            <a:noFill/>
+          </a:ln>
+          <a:effectLst/>
+        </p:spPr>
+        <p:style>
+          <a:lnRef idx="1">
+            <a:schemeClr val="accent1"/>
+          </a:lnRef>
+          <a:fillRef idx="3">
+            <a:schemeClr val="accent1"/>
+          </a:fillRef>
+          <a:effectRef idx="2">
+            <a:schemeClr val="accent1"/>
+          </a:effectRef>
+          <a:fontRef idx="minor">
+            <a:schemeClr val="lt1"/>
+          </a:fontRef>
+        </p:style>
+        <p:txBody>
+          <a:bodyPr rtlCol="0" anchor="ctr"/>
+          <a:lstStyle/>
+          <a:p>
+            <a:pPr algn="ctr"/>
+          </a:p>
+        </p:txBody>
+      </p:sp>
+      <p:sp>
+        <p:nvSpPr>
+          <p:cNvPr id="22" name="TextBox 21"/>
+          <p:cNvSpPr txBox="1"/>
+          <p:nvPr/>
+        </p:nvSpPr>
+        <p:spPr>
+          <a:xfrm>
+            <a:off x="411480" y="6565392"/>
+            <a:ext cx="5486400" cy="274320"/>
+          </a:xfrm>
+          <a:prstGeom prst="rect">
+            <a:avLst/>
+          </a:prstGeom>
+          <a:noFill/>
+        </p:spPr>
+        <p:txBody>
+          <a:bodyPr wrap="square" anchor="ctr" lIns="38100" rIns="38100" tIns="25400" bIns="25400">
+            <a:spAutoFit/>
+          </a:bodyPr>
+          <a:lstStyle/>
+          <a:p>
+            <a:pPr algn="l">
+              <a:lnSpc>
+                <a:spcPct val="106000"/>
+              </a:lnSpc>
+              <a:spcBef>
+                <a:spcPts val="0"/>
+              </a:spcBef>
+              <a:spcAft>
+                <a:spcPts val="200"/>
+              </a:spcAft>
+            </a:pPr>
+            <a:r>
+              <a:rPr sz="1100" b="1" i="0">
+                <a:solidFill>
+                  <a:srgbClr val="D64550"/>
+                </a:solidFill>
+                <a:latin typeface="Inter"/>
+              </a:rPr>
+              <a:t>● </a:t>
+            </a:r>
+            <a:r>
+              <a:rPr sz="950" b="0" i="0">
+                <a:solidFill>
+                  <a:srgbClr val="6A6E78"/>
+                </a:solidFill>
+                <a:latin typeface="Inter"/>
+              </a:rPr>
+              <a:t>U1 · PRESENTACIONES   ·   C4 · La Ruta</a:t>
+            </a:r>
+          </a:p>
+        </p:txBody>
+      </p:sp>
+      <p:sp>
+        <p:nvSpPr>
+          <p:cNvPr id="23" name="TextBox 22"/>
+          <p:cNvSpPr txBox="1"/>
+          <p:nvPr/>
+        </p:nvSpPr>
+        <p:spPr>
+          <a:xfrm>
+            <a:off x="8686800" y="6565392"/>
+            <a:ext cx="3063240" cy="274320"/>
+          </a:xfrm>
+          <a:prstGeom prst="rect">
+            <a:avLst/>
+          </a:prstGeom>
+          <a:noFill/>
+        </p:spPr>
+        <p:txBody>
+          <a:bodyPr wrap="square" anchor="ctr" lIns="38100" rIns="38100" tIns="25400" bIns="25400">
+            <a:spAutoFit/>
+          </a:bodyPr>
+          <a:lstStyle/>
+          <a:p>
+            <a:pPr algn="r">
+              <a:lnSpc>
+                <a:spcPct val="106000"/>
+              </a:lnSpc>
+              <a:spcBef>
+                <a:spcPts val="0"/>
+              </a:spcBef>
+              <a:spcAft>
+                <a:spcPts val="200"/>
+              </a:spcAft>
+            </a:pPr>
+            <a:r>
+              <a:rPr sz="900" b="0" i="1">
+                <a:solidFill>
+                  <a:srgbClr val="6A6E78"/>
+                </a:solidFill>
+                <a:latin typeface="Inter"/>
+              </a:rPr>
+              <a:t>Leerlingenversie — klik onthult</a:t>
+            </a:r>
+          </a:p>
+        </p:txBody>
+      </p:sp>
+      <p:sp>
+        <p:nvSpPr>
+          <p:cNvPr id="24" name="TextBox 23"/>
+          <p:cNvSpPr txBox="1"/>
+          <p:nvPr/>
+        </p:nvSpPr>
+        <p:spPr>
+          <a:xfrm>
+            <a:off x="11475720" y="6565392"/>
+            <a:ext cx="457200" cy="274320"/>
+          </a:xfrm>
+          <a:prstGeom prst="rect">
+            <a:avLst/>
+          </a:prstGeom>
+          <a:noFill/>
+        </p:spPr>
+        <p:txBody>
+          <a:bodyPr wrap="square" anchor="ctr" lIns="38100" rIns="38100" tIns="25400" bIns="25400">
+            <a:spAutoFit/>
+          </a:bodyPr>
+          <a:lstStyle/>
+          <a:p>
+            <a:pPr algn="r">
+              <a:lnSpc>
+                <a:spcPct val="106000"/>
+              </a:lnSpc>
+              <a:spcBef>
+                <a:spcPts val="0"/>
+              </a:spcBef>
+              <a:spcAft>
+                <a:spcPts val="200"/>
+              </a:spcAft>
+            </a:pPr>
+            <a:r>
+              <a:rPr sz="950" b="1" i="0">
+                <a:solidFill>
+                  <a:srgbClr val="A8323B"/>
+                </a:solidFill>
+                <a:latin typeface="Inter"/>
+              </a:rPr>
+              <a:t>13</a:t>
+            </a:r>
+          </a:p>
+        </p:txBody>
+      </p:sp>
+    </p:spTree>
+  </p:cSld>
+  <p:clrMapOvr>
+    <a:masterClrMapping/>
+  </p:clrMapOvr>
+</p:sld>
+</file>
+
+<file path=ppt/slides/slide14.xml><?xml version="1.0" encoding="utf-8"?>
+<p:sld xmlns:a="http://schemas.openxmlformats.org/drawingml/2006/main" xmlns:p="http://schemas.openxmlformats.org/presentationml/2006/main" xmlns:r="http://schemas.openxmlformats.org/officeDocument/2006/relationships">
+  <p:cSld>
+    <p:spTree>
+      <p:nvGrpSpPr>
+        <p:cNvPr id="1" name=""/>
+        <p:cNvGrpSpPr/>
+        <p:nvPr/>
+      </p:nvGrpSpPr>
+      <p:grpSpPr/>
+      <p:sp>
+        <p:nvSpPr>
+          <p:cNvPr id="2" name="Rectangle 1"/>
+          <p:cNvSpPr/>
+          <p:nvPr/>
+        </p:nvSpPr>
+        <p:spPr>
+          <a:xfrm>
+            <a:off x="0" y="0"/>
+            <a:ext cx="12191695" cy="6858000"/>
+          </a:xfrm>
+          <a:prstGeom prst="rect">
+            <a:avLst/>
+          </a:prstGeom>
+          <a:solidFill>
+            <a:srgbClr val="FCFBF8"/>
+          </a:solidFill>
+          <a:ln>
+            <a:noFill/>
+          </a:ln>
+          <a:effectLst/>
+        </p:spPr>
+        <p:style>
+          <a:lnRef idx="1">
+            <a:schemeClr val="accent1"/>
+          </a:lnRef>
+          <a:fillRef idx="3">
+            <a:schemeClr val="accent1"/>
+          </a:fillRef>
+          <a:effectRef idx="2">
+            <a:schemeClr val="accent1"/>
+          </a:effectRef>
+          <a:fontRef idx="minor">
+            <a:schemeClr val="lt1"/>
+          </a:fontRef>
+        </p:style>
+        <p:txBody>
+          <a:bodyPr rtlCol="0" anchor="ctr"/>
+          <a:lstStyle/>
+          <a:p>
+            <a:pPr algn="ctr"/>
+          </a:p>
+        </p:txBody>
+      </p:sp>
+      <p:sp>
+        <p:nvSpPr>
+          <p:cNvPr id="3" name="Rectangle 2"/>
+          <p:cNvSpPr/>
+          <p:nvPr/>
+        </p:nvSpPr>
+        <p:spPr>
+          <a:xfrm>
+            <a:off x="0" y="0"/>
+            <a:ext cx="12191695" cy="1078992"/>
+          </a:xfrm>
+          <a:prstGeom prst="rect">
+            <a:avLst/>
+          </a:prstGeom>
+          <a:solidFill>
+            <a:srgbClr val="D64550"/>
+          </a:solidFill>
+          <a:ln>
+            <a:noFill/>
+          </a:ln>
+          <a:effectLst/>
+        </p:spPr>
+        <p:style>
+          <a:lnRef idx="1">
+            <a:schemeClr val="accent1"/>
+          </a:lnRef>
+          <a:fillRef idx="3">
+            <a:schemeClr val="accent1"/>
+          </a:fillRef>
+          <a:effectRef idx="2">
+            <a:schemeClr val="accent1"/>
+          </a:effectRef>
+          <a:fontRef idx="minor">
+            <a:schemeClr val="lt1"/>
+          </a:fontRef>
+        </p:style>
+        <p:txBody>
+          <a:bodyPr rtlCol="0" anchor="ctr"/>
+          <a:lstStyle/>
+          <a:p>
+            <a:pPr algn="ctr"/>
+          </a:p>
+        </p:txBody>
+      </p:sp>
+      <p:sp>
+        <p:nvSpPr>
+          <p:cNvPr id="4" name="Rectangle 3"/>
+          <p:cNvSpPr/>
+          <p:nvPr/>
+        </p:nvSpPr>
+        <p:spPr>
+          <a:xfrm>
+            <a:off x="0" y="1078992"/>
+            <a:ext cx="12191695" cy="54864"/>
+          </a:xfrm>
+          <a:prstGeom prst="rect">
+            <a:avLst/>
+          </a:prstGeom>
+          <a:solidFill>
+            <a:srgbClr val="A8323B"/>
+          </a:solidFill>
+          <a:ln>
+            <a:noFill/>
+          </a:ln>
+          <a:effectLst/>
+        </p:spPr>
+        <p:style>
+          <a:lnRef idx="1">
+            <a:schemeClr val="accent1"/>
+          </a:lnRef>
+          <a:fillRef idx="3">
+            <a:schemeClr val="accent1"/>
+          </a:fillRef>
+          <a:effectRef idx="2">
+            <a:schemeClr val="accent1"/>
+          </a:effectRef>
+          <a:fontRef idx="minor">
+            <a:schemeClr val="lt1"/>
+          </a:fontRef>
+        </p:style>
+        <p:txBody>
+          <a:bodyPr rtlCol="0" anchor="ctr"/>
+          <a:lstStyle/>
+          <a:p>
+            <a:pPr algn="ctr"/>
+          </a:p>
+        </p:txBody>
+      </p:sp>
+      <p:sp>
+        <p:nvSpPr>
+          <p:cNvPr id="5" name="Rounded Rectangle 4"/>
+          <p:cNvSpPr/>
+          <p:nvPr/>
+        </p:nvSpPr>
+        <p:spPr>
+          <a:xfrm>
+            <a:off x="502920" y="182880"/>
             <a:ext cx="623620" cy="292608"/>
           </a:xfrm>
           <a:prstGeom prst="roundRect">
@@ -8295,7 +9449,7 @@
                 </a:solidFill>
                 <a:latin typeface="Inter"/>
               </a:rPr>
-              <a:t>13</a:t>
+              <a:t>14</a:t>
             </a:r>
           </a:p>
         </p:txBody>

</xml_diff>